<commit_message>
Add the other 3 team members to the mid-review deck
Team roster (name + roll no.) pulled from slides/build_mid_sem_ppt.py in
the Mondrian-Conformal-Prediction-On-Discrete-Event-Simulation repo, same
org -- same team works across both course projects. Title slide now lists
all four names; closing slide's contributor panel expanded from one person
to a compact 4-row list with roll numbers, reclaiming space from the
references block (which had more room than it needed).
</commit_message>
<xml_diff>
--- a/docs/mid_review_update.pptx
+++ b/docs/mid_review_update.pptx
@@ -3356,7 +3356,7 @@
         <p:spPr>
           <a:xfrm>
             <a:off x="640080" y="5989320"/>
-            <a:ext cx="7315200" cy="320040"/>
+            <a:ext cx="10852800" cy="320040"/>
           </a:xfrm>
           <a:prstGeom prst="rect">
             <a:avLst/>
@@ -3377,7 +3377,7 @@
                 </a:solidFill>
                 <a:latin typeface="Calibri"/>
               </a:rPr>
-              <a:t>Venugopalan Gangadharan</a:t>
+              <a:t>Venugopalan Gangadharan · Vipin Sudhakar · Rithvik Arulprakash · Harshith Kv</a:t>
             </a:r>
           </a:p>
         </p:txBody>
@@ -4081,7 +4081,7 @@
         <p:spPr>
           <a:xfrm>
             <a:off x="7218680" y="2130000"/>
-            <a:ext cx="4332935" cy="1900000"/>
+            <a:ext cx="4332935" cy="950000"/>
           </a:xfrm>
           <a:prstGeom prst="rect">
             <a:avLst/>
@@ -4099,11 +4099,11 @@
                 <a:spcPct val="112000"/>
               </a:lnSpc>
               <a:spcAft>
-                <a:spcPts val="700"/>
+                <a:spcPts val="500"/>
               </a:spcAft>
             </a:pPr>
             <a:r>
-              <a:rPr sz="1050" b="0">
+              <a:rPr sz="1000" b="0">
                 <a:solidFill>
                   <a:srgbClr val="1A202C"/>
                 </a:solidFill>
@@ -4118,11 +4118,11 @@
                 <a:spcPct val="112000"/>
               </a:lnSpc>
               <a:spcAft>
-                <a:spcPts val="700"/>
+                <a:spcPts val="500"/>
               </a:spcAft>
             </a:pPr>
             <a:r>
-              <a:rPr sz="1050" b="0">
+              <a:rPr sz="1000" b="0">
                 <a:solidFill>
                   <a:srgbClr val="1A202C"/>
                 </a:solidFill>
@@ -4137,11 +4137,11 @@
                 <a:spcPct val="112000"/>
               </a:lnSpc>
               <a:spcAft>
-                <a:spcPts val="700"/>
+                <a:spcPts val="500"/>
               </a:spcAft>
             </a:pPr>
             <a:r>
-              <a:rPr sz="1050" b="0">
+              <a:rPr sz="1000" b="0">
                 <a:solidFill>
                   <a:srgbClr val="1A202C"/>
                 </a:solidFill>
@@ -4156,11 +4156,11 @@
                 <a:spcPct val="112000"/>
               </a:lnSpc>
               <a:spcAft>
-                <a:spcPts val="700"/>
+                <a:spcPts val="500"/>
               </a:spcAft>
             </a:pPr>
             <a:r>
-              <a:rPr sz="1050" b="0">
+              <a:rPr sz="1000" b="0">
                 <a:solidFill>
                   <a:srgbClr val="1A202C"/>
                 </a:solidFill>
@@ -4179,7 +4179,7 @@
         </p:nvSpPr>
         <p:spPr>
           <a:xfrm>
-            <a:off x="7218680" y="4100000"/>
+            <a:off x="7218680" y="3100000"/>
             <a:ext cx="4332935" cy="18288"/>
           </a:xfrm>
           <a:prstGeom prst="rect">
@@ -4223,7 +4223,7 @@
         </p:nvSpPr>
         <p:spPr>
           <a:xfrm>
-            <a:off x="7218680" y="4260000"/>
+            <a:off x="7218680" y="3260000"/>
             <a:ext cx="4332935" cy="320040"/>
           </a:xfrm>
           <a:prstGeom prst="rect">
@@ -4245,7 +4245,7 @@
                 </a:solidFill>
                 <a:latin typeface="Calibri"/>
               </a:rPr>
-              <a:t>CONTRIBUTOR</a:t>
+              <a:t>CONTRIBUTORS</a:t>
             </a:r>
           </a:p>
         </p:txBody>
@@ -4258,8 +4258,8 @@
         </p:nvSpPr>
         <p:spPr>
           <a:xfrm>
-            <a:off x="7218680" y="4560000"/>
-            <a:ext cx="4332935" cy="360000"/>
+            <a:off x="7218680" y="3600000"/>
+            <a:ext cx="4332935" cy="1080000"/>
           </a:xfrm>
           <a:prstGeom prst="rect">
             <a:avLst/>
@@ -4272,15 +4272,79 @@
           </a:bodyPr>
           <a:lstStyle/>
           <a:p>
-            <a:pPr algn="l"/>
-            <a:r>
-              <a:rPr sz="1400" b="1">
+            <a:pPr>
+              <a:lnSpc>
+                <a:spcPct val="112000"/>
+              </a:lnSpc>
+              <a:spcAft>
+                <a:spcPts val="600"/>
+              </a:spcAft>
+            </a:pPr>
+            <a:r>
+              <a:rPr sz="1050" b="1">
                 <a:solidFill>
                   <a:srgbClr val="1A202C"/>
                 </a:solidFill>
                 <a:latin typeface="Calibri"/>
               </a:rPr>
-              <a:t>Venugopalan Gangadharan</a:t>
+              <a:t>▸  Venugopalan Gangadharan — CB.AI.U4AID25115</a:t>
+            </a:r>
+          </a:p>
+          <a:p>
+            <a:pPr>
+              <a:lnSpc>
+                <a:spcPct val="112000"/>
+              </a:lnSpc>
+              <a:spcAft>
+                <a:spcPts val="600"/>
+              </a:spcAft>
+            </a:pPr>
+            <a:r>
+              <a:rPr sz="1050" b="1">
+                <a:solidFill>
+                  <a:srgbClr val="1A202C"/>
+                </a:solidFill>
+                <a:latin typeface="Calibri"/>
+              </a:rPr>
+              <a:t>▸  Vipin Sudhakar — CB.AI.U4AID25166</a:t>
+            </a:r>
+          </a:p>
+          <a:p>
+            <a:pPr>
+              <a:lnSpc>
+                <a:spcPct val="112000"/>
+              </a:lnSpc>
+              <a:spcAft>
+                <a:spcPts val="600"/>
+              </a:spcAft>
+            </a:pPr>
+            <a:r>
+              <a:rPr sz="1050" b="1">
+                <a:solidFill>
+                  <a:srgbClr val="1A202C"/>
+                </a:solidFill>
+                <a:latin typeface="Calibri"/>
+              </a:rPr>
+              <a:t>▸  Rithvik Arulprakash — CB.AI.U4AID25148</a:t>
+            </a:r>
+          </a:p>
+          <a:p>
+            <a:pPr>
+              <a:lnSpc>
+                <a:spcPct val="112000"/>
+              </a:lnSpc>
+              <a:spcAft>
+                <a:spcPts val="600"/>
+              </a:spcAft>
+            </a:pPr>
+            <a:r>
+              <a:rPr sz="1050" b="1">
+                <a:solidFill>
+                  <a:srgbClr val="1A202C"/>
+                </a:solidFill>
+                <a:latin typeface="Calibri"/>
+              </a:rPr>
+              <a:t>▸  Harshith Kv — CB.AI.U4AID25119</a:t>
             </a:r>
           </a:p>
         </p:txBody>
@@ -4293,8 +4357,8 @@
         </p:nvSpPr>
         <p:spPr>
           <a:xfrm>
-            <a:off x="7218680" y="4910000"/>
-            <a:ext cx="4332935" cy="500000"/>
+            <a:off x="7218680" y="4700000"/>
+            <a:ext cx="4332935" cy="360000"/>
           </a:xfrm>
           <a:prstGeom prst="rect">
             <a:avLst/>
@@ -4309,7 +4373,7 @@
           <a:p>
             <a:pPr algn="l"/>
             <a:r>
-              <a:rPr sz="1050" b="0">
+              <a:rPr sz="1000" b="0">
                 <a:solidFill>
                   <a:srgbClr val="475569"/>
                 </a:solidFill>
@@ -4328,7 +4392,7 @@
         </p:nvSpPr>
         <p:spPr>
           <a:xfrm>
-            <a:off x="7218680" y="5450000"/>
+            <a:off x="7218680" y="5150000"/>
             <a:ext cx="4332935" cy="320040"/>
           </a:xfrm>
           <a:prstGeom prst="rect">
@@ -4363,7 +4427,7 @@
         </p:nvSpPr>
         <p:spPr>
           <a:xfrm>
-            <a:off x="7218680" y="5750000"/>
+            <a:off x="7218680" y="5450000"/>
             <a:ext cx="4332935" cy="500000"/>
           </a:xfrm>
           <a:prstGeom prst="rect">

</xml_diff>